<commit_message>
week 7 - day 5: fix html
</commit_message>
<xml_diff>
--- a/week7/day5/Scout_presentation.pptx
+++ b/week7/day5/Scout_presentation.pptx
@@ -7314,6 +7314,10 @@
             <a:prstDash val="solid"/>
           </a:ln>
         </p:spPr>
+        <p:txBody>
+          <a:bodyPr/>
+          <a:p/>
+        </p:txBody>
       </p:sp>
       <p:sp>
         <p:nvSpPr>
@@ -7434,6 +7438,27 @@
                 <a:cs typeface="Calibri" pitchFamily="34" charset="-120"/>
               </a:rPr>
               <a:t>Videos without captions get a weaker summary</a:t>
+            </a:r>
+            <a:endParaRPr lang="en-US" sz="1400" dirty="0"/>
+          </a:p>
+          <a:p>
+            <a:pPr marL="342900" indent="-342900">
+              <a:spcAft>
+                <a:spcPts val="1000"/>
+              </a:spcAft>
+              <a:buSzPct val="100000"/>
+              <a:buChar char="•"/>
+            </a:pPr>
+            <a:r>
+              <a:rPr lang="en-US" sz="1400" dirty="0">
+                <a:solidFill>
+                  <a:srgbClr val="5A6675"/>
+                </a:solidFill>
+                <a:latin typeface="Calibri" pitchFamily="34" charset="0"/>
+                <a:ea typeface="Calibri" pitchFamily="34" charset="-122"/>
+                <a:cs typeface="Calibri" pitchFamily="34" charset="-120"/>
+              </a:rPr>
+              <a:t>Summaries aren't cached — the same link costs twice</a:t>
             </a:r>
             <a:endParaRPr lang="en-US" sz="1400" dirty="0"/>
           </a:p>
@@ -7465,6 +7490,10 @@
             <a:prstDash val="solid"/>
           </a:ln>
         </p:spPr>
+        <p:txBody>
+          <a:bodyPr/>
+          <a:p/>
+        </p:txBody>
       </p:sp>
       <p:sp>
         <p:nvSpPr>
@@ -7563,7 +7592,7 @@
                 <a:ea typeface="Calibri" pitchFamily="34" charset="-122"/>
                 <a:cs typeface="Calibri" pitchFamily="34" charset="-120"/>
               </a:rPr>
-              <a:t>A proper database instead of a file</a:t>
+              <a:t>A database for config, to stop overwrites</a:t>
             </a:r>
             <a:endParaRPr lang="en-US" sz="1400" dirty="0"/>
           </a:p>

</xml_diff>